<commit_message>
Update submission deck with live GitHub repo link
</commit_message>
<xml_diff>
--- a/AICTE_Project_Submission_Rishabh_Bansal_Recipe_Agent.pptx
+++ b/AICTE_Project_Submission_Rishabh_Bansal_Recipe_Agent.pptx
@@ -15764,30 +15764,31 @@
                 </a:solidFill>
                 <a:latin typeface="Arial"/>
               </a:rPr>
-              <a:t>· Please create a public GitHub repository (enable “Add README” while creating it).</a:t>
+              <a:t>· Public GitHub repository created (with README) – </a:t>
             </a:r>
             <a:endParaRPr/>
           </a:p>
           <a:p>
             <a:r>
-              <a:rPr sz="1300" b="0">
+              <a:rPr sz="1300" b="1">
                 <a:solidFill>
                   <a:srgbClr val="000000"/>
                 </a:solidFill>
                 <a:latin typeface="Arial"/>
               </a:rPr>
-              <a:t>· Suggested repository name/URL (create this under your own GitHub account) – </a:t>
+              <a:t>https://github.com/rishabh230707-afk/eco-lifestyle-agent</a:t>
             </a:r>
           </a:p>
+          <a:p/>
           <a:p>
             <a:r>
-              <a:rPr sz="1300" b="1">
+              <a:rPr sz="1300" b="0">
                 <a:solidFill>
                   <a:srgbClr val="000000"/>
                 </a:solidFill>
                 <a:latin typeface="Arial"/>
               </a:rPr>
-              <a:t>https://github.com/rishabhb2307/eco-lifestyle-agent</a:t>
+              <a:t>· Files uploaded: README.md, app.json, problem_statement.md, and this project presentation (.pptx).</a:t>
             </a:r>
           </a:p>
           <a:p>
@@ -15798,29 +15799,7 @@
                 </a:solidFill>
                 <a:latin typeface="Arial"/>
               </a:rPr>
-              <a:t>  — this is a suggested name only; it has not been created or verified. Please create it yourself and replace this with the real, working URL.</a:t>
-            </a:r>
-          </a:p>
-          <a:p>
-            <a:r>
-              <a:rPr sz="1300" b="0">
-                <a:solidFill>
-                  <a:srgbClr val="000000"/>
-                </a:solidFill>
-                <a:latin typeface="Arial"/>
-              </a:rPr>
-              <a:t>· Make sure you have uploaded the following files to your GitHub repository:</a:t>
-            </a:r>
-          </a:p>
-          <a:p>
-            <a:r>
-              <a:rPr sz="1300" b="0">
-                <a:solidFill>
-                  <a:srgbClr val="000000"/>
-                </a:solidFill>
-                <a:latin typeface="Arial"/>
-              </a:rPr>
-              <a:t>   1) app.json file   2) your problem-statement PDF   3) your project presentation .pptx file   4) any other supporting files</a:t>
+              <a:t>· Note: app.json currently contains placeholder values — replace with your real exported agent configuration from watsonx Orchestrate before final submission.</a:t>
             </a:r>
           </a:p>
         </p:txBody>

</xml_diff>